<commit_message>
Add measured personalization to the model deck + a detailed model-presentation PDF
- model_slides.pptx (now 15 slides): adds a "Does personalization help? (measured)"
  slide with the real ablation numbers — Glasgow +0.038, Osaka -0.007, Toronto -0.017
  (Edinburgh/Melbourne deferred to the GPU run). Honest "mixed / cold-start" framing.
- model_explained.pdf (new, 7 pages): a plain-language companion explaining every slide
  of the jury deck — the engine architecture component-by-component, why it carries the
  title, Strategy A (with the rollout diagram + worked Edinburgh example), the A-vs-B
  result, validation, and the supporting experiments incl. the personalization table.
- flickr_results_data.py: PERSONALIZATION (3 cities measured locally; 2 pending GPU).
- results/flickr/personalization.json: the measured ablation.

Co-Authored-By: Claude Opus 4.8 (1M context) <noreply@anthropic.com>
</commit_message>
<xml_diff>
--- a/presentation/strategy_d/model_slides.pptx
+++ b/presentation/strategy_d/model_slides.pptx
@@ -19,6 +19,7 @@
     <p:sldId id="267" r:id="rId18"/>
     <p:sldId id="268" r:id="rId19"/>
     <p:sldId id="269" r:id="rId20"/>
+    <p:sldId id="270" r:id="rId21"/>
   </p:sldIdLst>
   <p:sldSz cx="12191695" cy="6858000" type="screen4x3"/>
   <p:notesSz cx="6858000" cy="9144000"/>
@@ -4929,7 +4930,7 @@
                 </a:solidFill>
                 <a:latin typeface="Calibri"/>
               </a:rPr>
-              <a:t> I ablate the user embedding (on/off) per city — it can help where tourists recur (55–61% of Edinburgh/Melbourne/Toronto), little on Osaka/Glasgow.</a:t>
+              <a:t> I ablate the user embedding (on/off) per city — measured on the next slide.</a:t>
             </a:r>
           </a:p>
         </p:txBody>
@@ -5140,7 +5141,7 @@
                 </a:solidFill>
                 <a:latin typeface="Calibri"/>
               </a:rPr>
-              <a:t>Limitations &amp; future work</a:t>
+              <a:t>Does personalization help? (measured)</a:t>
             </a:r>
           </a:p>
         </p:txBody>
@@ -5175,7 +5176,7 @@
                 </a:solidFill>
                 <a:latin typeface="Calibri"/>
               </a:rPr>
-              <a:t>honesty</a:t>
+              <a:t>the “user preferences” claim</a:t>
             </a:r>
           </a:p>
         </p:txBody>
@@ -5188,8 +5189,657 @@
         </p:nvSpPr>
         <p:spPr>
           <a:xfrm>
-            <a:off x="640080" y="1463040"/>
-            <a:ext cx="10972800" cy="4572000"/>
+            <a:off x="502920" y="1234440"/>
+            <a:ext cx="11155680" cy="457200"/>
+          </a:xfrm>
+          <a:prstGeom prst="rect">
+            <a:avLst/>
+          </a:prstGeom>
+          <a:noFill/>
+        </p:spPr>
+        <p:txBody>
+          <a:bodyPr wrap="square" anchor="t">
+            <a:spAutoFit/>
+          </a:bodyPr>
+          <a:lstStyle/>
+          <a:p>
+            <a:pPr algn="l"/>
+            <a:r>
+              <a:rPr sz="1500" b="0" i="0">
+                <a:solidFill>
+                  <a:srgbClr val="555555"/>
+                </a:solidFill>
+                <a:latin typeface="Calibri"/>
+              </a:rPr>
+              <a:t>I switch the user embedding OFF vs ON (identical otherwise) on the comparable Flickr benchmark:</a:t>
+            </a:r>
+          </a:p>
+        </p:txBody>
+      </p:sp>
+      <p:graphicFrame>
+        <p:nvGraphicFramePr>
+          <p:cNvPr id="7" name="Table 6"/>
+          <p:cNvGraphicFramePr>
+            <a:graphicFrameLocks noGrp="1"/>
+          </p:cNvGraphicFramePr>
+          <p:nvPr/>
+        </p:nvGraphicFramePr>
+        <p:xfrm>
+          <a:off x="1463040" y="1920240"/>
+          <a:ext cx="9235440" cy="2377440"/>
+        </p:xfrm>
+        <a:graphic>
+          <a:graphicData uri="http://schemas.openxmlformats.org/drawingml/2006/table">
+            <a:tbl>
+              <a:tblPr firstRow="1" bandRow="1">
+                <a:tableStyleId>{5C22544A-7EE6-4342-B048-85BDC9FD1C3A}</a:tableStyleId>
+              </a:tblPr>
+              <a:tblGrid>
+                <a:gridCol w="1847088"/>
+                <a:gridCol w="1847088"/>
+                <a:gridCol w="1847088"/>
+                <a:gridCol w="1847088"/>
+                <a:gridCol w="1847088"/>
+              </a:tblGrid>
+              <a:tr h="475488">
+                <a:tc>
+                  <a:txBody>
+                    <a:bodyPr/>
+                    <a:lstStyle/>
+                    <a:p>
+                      <a:pPr algn="l"/>
+                      <a:r>
+                        <a:rPr sz="1300" b="1">
+                          <a:solidFill>
+                            <a:srgbClr val="FFFFFF"/>
+                          </a:solidFill>
+                          <a:latin typeface="Calibri"/>
+                        </a:rPr>
+                        <a:t>City</a:t>
+                      </a:r>
+                    </a:p>
+                  </a:txBody>
+                  <a:tcPr marT="38100" marB="38100" anchor="ctr">
+                    <a:solidFill>
+                      <a:srgbClr val="1B2A4E"/>
+                    </a:solidFill>
+                  </a:tcPr>
+                </a:tc>
+                <a:tc>
+                  <a:txBody>
+                    <a:bodyPr/>
+                    <a:lstStyle/>
+                    <a:p>
+                      <a:pPr algn="ctr"/>
+                      <a:r>
+                        <a:rPr sz="1300" b="1">
+                          <a:solidFill>
+                            <a:srgbClr val="FFFFFF"/>
+                          </a:solidFill>
+                          <a:latin typeface="Calibri"/>
+                        </a:rPr>
+                        <a:t>no user</a:t>
+                      </a:r>
+                    </a:p>
+                  </a:txBody>
+                  <a:tcPr marT="38100" marB="38100" anchor="ctr">
+                    <a:solidFill>
+                      <a:srgbClr val="1B2A4E"/>
+                    </a:solidFill>
+                  </a:tcPr>
+                </a:tc>
+                <a:tc>
+                  <a:txBody>
+                    <a:bodyPr/>
+                    <a:lstStyle/>
+                    <a:p>
+                      <a:pPr algn="ctr"/>
+                      <a:r>
+                        <a:rPr sz="1300" b="1">
+                          <a:solidFill>
+                            <a:srgbClr val="FFFFFF"/>
+                          </a:solidFill>
+                          <a:latin typeface="Calibri"/>
+                        </a:rPr>
+                        <a:t>with user</a:t>
+                      </a:r>
+                    </a:p>
+                  </a:txBody>
+                  <a:tcPr marT="38100" marB="38100" anchor="ctr">
+                    <a:solidFill>
+                      <a:srgbClr val="1B2A4E"/>
+                    </a:solidFill>
+                  </a:tcPr>
+                </a:tc>
+                <a:tc>
+                  <a:txBody>
+                    <a:bodyPr/>
+                    <a:lstStyle/>
+                    <a:p>
+                      <a:pPr algn="ctr"/>
+                      <a:r>
+                        <a:rPr sz="1300" b="1">
+                          <a:solidFill>
+                            <a:srgbClr val="FFFFFF"/>
+                          </a:solidFill>
+                          <a:latin typeface="Calibri"/>
+                        </a:rPr>
+                        <a:t>delta</a:t>
+                      </a:r>
+                    </a:p>
+                  </a:txBody>
+                  <a:tcPr marT="38100" marB="38100" anchor="ctr">
+                    <a:solidFill>
+                      <a:srgbClr val="1B2A4E"/>
+                    </a:solidFill>
+                  </a:tcPr>
+                </a:tc>
+                <a:tc>
+                  <a:txBody>
+                    <a:bodyPr/>
+                    <a:lstStyle/>
+                    <a:p>
+                      <a:pPr algn="ctr"/>
+                      <a:r>
+                        <a:rPr sz="1300" b="1">
+                          <a:solidFill>
+                            <a:srgbClr val="FFFFFF"/>
+                          </a:solidFill>
+                          <a:latin typeface="Calibri"/>
+                        </a:rPr>
+                        <a:t>recurring users</a:t>
+                      </a:r>
+                    </a:p>
+                  </a:txBody>
+                  <a:tcPr marT="38100" marB="38100" anchor="ctr">
+                    <a:solidFill>
+                      <a:srgbClr val="1B2A4E"/>
+                    </a:solidFill>
+                  </a:tcPr>
+                </a:tc>
+              </a:tr>
+              <a:tr h="475488">
+                <a:tc>
+                  <a:txBody>
+                    <a:bodyPr/>
+                    <a:lstStyle/>
+                    <a:p>
+                      <a:pPr algn="l"/>
+                      <a:r>
+                        <a:rPr sz="1300">
+                          <a:solidFill>
+                            <a:srgbClr val="555555"/>
+                          </a:solidFill>
+                          <a:latin typeface="Calibri"/>
+                        </a:rPr>
+                        <a:t>Osaka</a:t>
+                      </a:r>
+                    </a:p>
+                  </a:txBody>
+                  <a:tcPr marT="38100" marB="38100" anchor="ctr">
+                    <a:solidFill>
+                      <a:srgbClr val="FFFFFF"/>
+                    </a:solidFill>
+                  </a:tcPr>
+                </a:tc>
+                <a:tc>
+                  <a:txBody>
+                    <a:bodyPr/>
+                    <a:lstStyle/>
+                    <a:p>
+                      <a:pPr algn="ctr"/>
+                      <a:r>
+                        <a:rPr sz="1300">
+                          <a:solidFill>
+                            <a:srgbClr val="555555"/>
+                          </a:solidFill>
+                          <a:latin typeface="Calibri"/>
+                        </a:rPr>
+                        <a:t>0.442</a:t>
+                      </a:r>
+                    </a:p>
+                  </a:txBody>
+                  <a:tcPr marT="38100" marB="38100" anchor="ctr">
+                    <a:solidFill>
+                      <a:srgbClr val="FFFFFF"/>
+                    </a:solidFill>
+                  </a:tcPr>
+                </a:tc>
+                <a:tc>
+                  <a:txBody>
+                    <a:bodyPr/>
+                    <a:lstStyle/>
+                    <a:p>
+                      <a:pPr algn="ctr"/>
+                      <a:r>
+                        <a:rPr sz="1300">
+                          <a:solidFill>
+                            <a:srgbClr val="555555"/>
+                          </a:solidFill>
+                          <a:latin typeface="Calibri"/>
+                        </a:rPr>
+                        <a:t>0.435</a:t>
+                      </a:r>
+                    </a:p>
+                  </a:txBody>
+                  <a:tcPr marT="38100" marB="38100" anchor="ctr">
+                    <a:solidFill>
+                      <a:srgbClr val="FFFFFF"/>
+                    </a:solidFill>
+                  </a:tcPr>
+                </a:tc>
+                <a:tc>
+                  <a:txBody>
+                    <a:bodyPr/>
+                    <a:lstStyle/>
+                    <a:p>
+                      <a:pPr algn="ctr"/>
+                      <a:r>
+                        <a:rPr sz="1300">
+                          <a:solidFill>
+                            <a:srgbClr val="555555"/>
+                          </a:solidFill>
+                          <a:latin typeface="Calibri"/>
+                        </a:rPr>
+                        <a:t>-0.007</a:t>
+                      </a:r>
+                    </a:p>
+                  </a:txBody>
+                  <a:tcPr marT="38100" marB="38100" anchor="ctr">
+                    <a:solidFill>
+                      <a:srgbClr val="FFFFFF"/>
+                    </a:solidFill>
+                  </a:tcPr>
+                </a:tc>
+                <a:tc>
+                  <a:txBody>
+                    <a:bodyPr/>
+                    <a:lstStyle/>
+                    <a:p>
+                      <a:pPr algn="ctr"/>
+                      <a:r>
+                        <a:rPr sz="1300">
+                          <a:solidFill>
+                            <a:srgbClr val="555555"/>
+                          </a:solidFill>
+                          <a:latin typeface="Calibri"/>
+                        </a:rPr>
+                        <a:t>28%</a:t>
+                      </a:r>
+                    </a:p>
+                  </a:txBody>
+                  <a:tcPr marT="38100" marB="38100" anchor="ctr">
+                    <a:solidFill>
+                      <a:srgbClr val="FFFFFF"/>
+                    </a:solidFill>
+                  </a:tcPr>
+                </a:tc>
+              </a:tr>
+              <a:tr h="475488">
+                <a:tc>
+                  <a:txBody>
+                    <a:bodyPr/>
+                    <a:lstStyle/>
+                    <a:p>
+                      <a:pPr algn="l"/>
+                      <a:r>
+                        <a:rPr sz="1300" b="1">
+                          <a:solidFill>
+                            <a:srgbClr val="FFFFFF"/>
+                          </a:solidFill>
+                          <a:latin typeface="Calibri"/>
+                        </a:rPr>
+                        <a:t>Glasgow</a:t>
+                      </a:r>
+                    </a:p>
+                  </a:txBody>
+                  <a:tcPr marT="38100" marB="38100" anchor="ctr">
+                    <a:solidFill>
+                      <a:srgbClr val="0E7C7B"/>
+                    </a:solidFill>
+                  </a:tcPr>
+                </a:tc>
+                <a:tc>
+                  <a:txBody>
+                    <a:bodyPr/>
+                    <a:lstStyle/>
+                    <a:p>
+                      <a:pPr algn="ctr"/>
+                      <a:r>
+                        <a:rPr sz="1300" b="1">
+                          <a:solidFill>
+                            <a:srgbClr val="FFFFFF"/>
+                          </a:solidFill>
+                          <a:latin typeface="Calibri"/>
+                        </a:rPr>
+                        <a:t>0.451</a:t>
+                      </a:r>
+                    </a:p>
+                  </a:txBody>
+                  <a:tcPr marT="38100" marB="38100" anchor="ctr">
+                    <a:solidFill>
+                      <a:srgbClr val="0E7C7B"/>
+                    </a:solidFill>
+                  </a:tcPr>
+                </a:tc>
+                <a:tc>
+                  <a:txBody>
+                    <a:bodyPr/>
+                    <a:lstStyle/>
+                    <a:p>
+                      <a:pPr algn="ctr"/>
+                      <a:r>
+                        <a:rPr sz="1300" b="1">
+                          <a:solidFill>
+                            <a:srgbClr val="FFFFFF"/>
+                          </a:solidFill>
+                          <a:latin typeface="Calibri"/>
+                        </a:rPr>
+                        <a:t>0.489</a:t>
+                      </a:r>
+                    </a:p>
+                  </a:txBody>
+                  <a:tcPr marT="38100" marB="38100" anchor="ctr">
+                    <a:solidFill>
+                      <a:srgbClr val="0E7C7B"/>
+                    </a:solidFill>
+                  </a:tcPr>
+                </a:tc>
+                <a:tc>
+                  <a:txBody>
+                    <a:bodyPr/>
+                    <a:lstStyle/>
+                    <a:p>
+                      <a:pPr algn="ctr"/>
+                      <a:r>
+                        <a:rPr sz="1300" b="1">
+                          <a:solidFill>
+                            <a:srgbClr val="FFFFFF"/>
+                          </a:solidFill>
+                          <a:latin typeface="Calibri"/>
+                        </a:rPr>
+                        <a:t>+0.038</a:t>
+                      </a:r>
+                    </a:p>
+                  </a:txBody>
+                  <a:tcPr marT="38100" marB="38100" anchor="ctr">
+                    <a:solidFill>
+                      <a:srgbClr val="0E7C7B"/>
+                    </a:solidFill>
+                  </a:tcPr>
+                </a:tc>
+                <a:tc>
+                  <a:txBody>
+                    <a:bodyPr/>
+                    <a:lstStyle/>
+                    <a:p>
+                      <a:pPr algn="ctr"/>
+                      <a:r>
+                        <a:rPr sz="1300" b="1">
+                          <a:solidFill>
+                            <a:srgbClr val="FFFFFF"/>
+                          </a:solidFill>
+                          <a:latin typeface="Calibri"/>
+                        </a:rPr>
+                        <a:t>32%</a:t>
+                      </a:r>
+                    </a:p>
+                  </a:txBody>
+                  <a:tcPr marT="38100" marB="38100" anchor="ctr">
+                    <a:solidFill>
+                      <a:srgbClr val="0E7C7B"/>
+                    </a:solidFill>
+                  </a:tcPr>
+                </a:tc>
+              </a:tr>
+              <a:tr h="475488">
+                <a:tc>
+                  <a:txBody>
+                    <a:bodyPr/>
+                    <a:lstStyle/>
+                    <a:p>
+                      <a:pPr algn="l"/>
+                      <a:r>
+                        <a:rPr sz="1300">
+                          <a:solidFill>
+                            <a:srgbClr val="555555"/>
+                          </a:solidFill>
+                          <a:latin typeface="Calibri"/>
+                        </a:rPr>
+                        <a:t>Toronto</a:t>
+                      </a:r>
+                    </a:p>
+                  </a:txBody>
+                  <a:tcPr marT="38100" marB="38100" anchor="ctr">
+                    <a:solidFill>
+                      <a:srgbClr val="FFFFFF"/>
+                    </a:solidFill>
+                  </a:tcPr>
+                </a:tc>
+                <a:tc>
+                  <a:txBody>
+                    <a:bodyPr/>
+                    <a:lstStyle/>
+                    <a:p>
+                      <a:pPr algn="ctr"/>
+                      <a:r>
+                        <a:rPr sz="1300">
+                          <a:solidFill>
+                            <a:srgbClr val="555555"/>
+                          </a:solidFill>
+                          <a:latin typeface="Calibri"/>
+                        </a:rPr>
+                        <a:t>0.440</a:t>
+                      </a:r>
+                    </a:p>
+                  </a:txBody>
+                  <a:tcPr marT="38100" marB="38100" anchor="ctr">
+                    <a:solidFill>
+                      <a:srgbClr val="FFFFFF"/>
+                    </a:solidFill>
+                  </a:tcPr>
+                </a:tc>
+                <a:tc>
+                  <a:txBody>
+                    <a:bodyPr/>
+                    <a:lstStyle/>
+                    <a:p>
+                      <a:pPr algn="ctr"/>
+                      <a:r>
+                        <a:rPr sz="1300">
+                          <a:solidFill>
+                            <a:srgbClr val="555555"/>
+                          </a:solidFill>
+                          <a:latin typeface="Calibri"/>
+                        </a:rPr>
+                        <a:t>0.423</a:t>
+                      </a:r>
+                    </a:p>
+                  </a:txBody>
+                  <a:tcPr marT="38100" marB="38100" anchor="ctr">
+                    <a:solidFill>
+                      <a:srgbClr val="FFFFFF"/>
+                    </a:solidFill>
+                  </a:tcPr>
+                </a:tc>
+                <a:tc>
+                  <a:txBody>
+                    <a:bodyPr/>
+                    <a:lstStyle/>
+                    <a:p>
+                      <a:pPr algn="ctr"/>
+                      <a:r>
+                        <a:rPr sz="1300">
+                          <a:solidFill>
+                            <a:srgbClr val="555555"/>
+                          </a:solidFill>
+                          <a:latin typeface="Calibri"/>
+                        </a:rPr>
+                        <a:t>-0.017</a:t>
+                      </a:r>
+                    </a:p>
+                  </a:txBody>
+                  <a:tcPr marT="38100" marB="38100" anchor="ctr">
+                    <a:solidFill>
+                      <a:srgbClr val="FFFFFF"/>
+                    </a:solidFill>
+                  </a:tcPr>
+                </a:tc>
+                <a:tc>
+                  <a:txBody>
+                    <a:bodyPr/>
+                    <a:lstStyle/>
+                    <a:p>
+                      <a:pPr algn="ctr"/>
+                      <a:r>
+                        <a:rPr sz="1300">
+                          <a:solidFill>
+                            <a:srgbClr val="555555"/>
+                          </a:solidFill>
+                          <a:latin typeface="Calibri"/>
+                        </a:rPr>
+                        <a:t>55%</a:t>
+                      </a:r>
+                    </a:p>
+                  </a:txBody>
+                  <a:tcPr marT="38100" marB="38100" anchor="ctr">
+                    <a:solidFill>
+                      <a:srgbClr val="FFFFFF"/>
+                    </a:solidFill>
+                  </a:tcPr>
+                </a:tc>
+              </a:tr>
+              <a:tr h="475488">
+                <a:tc>
+                  <a:txBody>
+                    <a:bodyPr/>
+                    <a:lstStyle/>
+                    <a:p>
+                      <a:pPr algn="l"/>
+                      <a:r>
+                        <a:rPr sz="1300">
+                          <a:solidFill>
+                            <a:srgbClr val="555555"/>
+                          </a:solidFill>
+                          <a:latin typeface="Calibri"/>
+                        </a:rPr>
+                        <a:t>Edinburgh, Melbourne</a:t>
+                      </a:r>
+                    </a:p>
+                  </a:txBody>
+                  <a:tcPr marT="38100" marB="38100" anchor="ctr">
+                    <a:solidFill>
+                      <a:srgbClr val="ECEEF3"/>
+                    </a:solidFill>
+                  </a:tcPr>
+                </a:tc>
+                <a:tc>
+                  <a:txBody>
+                    <a:bodyPr/>
+                    <a:lstStyle/>
+                    <a:p>
+                      <a:pPr algn="ctr"/>
+                      <a:r>
+                        <a:rPr sz="1300">
+                          <a:solidFill>
+                            <a:srgbClr val="555555"/>
+                          </a:solidFill>
+                          <a:latin typeface="Calibri"/>
+                        </a:rPr>
+                        <a:t>—</a:t>
+                      </a:r>
+                    </a:p>
+                  </a:txBody>
+                  <a:tcPr marT="38100" marB="38100" anchor="ctr">
+                    <a:solidFill>
+                      <a:srgbClr val="ECEEF3"/>
+                    </a:solidFill>
+                  </a:tcPr>
+                </a:tc>
+                <a:tc>
+                  <a:txBody>
+                    <a:bodyPr/>
+                    <a:lstStyle/>
+                    <a:p>
+                      <a:pPr algn="ctr"/>
+                      <a:r>
+                        <a:rPr sz="1300">
+                          <a:solidFill>
+                            <a:srgbClr val="555555"/>
+                          </a:solidFill>
+                          <a:latin typeface="Calibri"/>
+                        </a:rPr>
+                        <a:t>—</a:t>
+                      </a:r>
+                    </a:p>
+                  </a:txBody>
+                  <a:tcPr marT="38100" marB="38100" anchor="ctr">
+                    <a:solidFill>
+                      <a:srgbClr val="ECEEF3"/>
+                    </a:solidFill>
+                  </a:tcPr>
+                </a:tc>
+                <a:tc>
+                  <a:txBody>
+                    <a:bodyPr/>
+                    <a:lstStyle/>
+                    <a:p>
+                      <a:pPr algn="ctr"/>
+                      <a:r>
+                        <a:rPr sz="1300">
+                          <a:solidFill>
+                            <a:srgbClr val="555555"/>
+                          </a:solidFill>
+                          <a:latin typeface="Calibri"/>
+                        </a:rPr>
+                        <a:t>(GPU run)</a:t>
+                      </a:r>
+                    </a:p>
+                  </a:txBody>
+                  <a:tcPr marT="38100" marB="38100" anchor="ctr">
+                    <a:solidFill>
+                      <a:srgbClr val="ECEEF3"/>
+                    </a:solidFill>
+                  </a:tcPr>
+                </a:tc>
+                <a:tc>
+                  <a:txBody>
+                    <a:bodyPr/>
+                    <a:lstStyle/>
+                    <a:p>
+                      <a:pPr algn="ctr"/>
+                      <a:r>
+                        <a:rPr sz="1300">
+                          <a:solidFill>
+                            <a:srgbClr val="555555"/>
+                          </a:solidFill>
+                          <a:latin typeface="Calibri"/>
+                        </a:rPr>
+                        <a:t>59%, 61%</a:t>
+                      </a:r>
+                    </a:p>
+                  </a:txBody>
+                  <a:tcPr marT="38100" marB="38100" anchor="ctr">
+                    <a:solidFill>
+                      <a:srgbClr val="ECEEF3"/>
+                    </a:solidFill>
+                  </a:tcPr>
+                </a:tc>
+              </a:tr>
+            </a:tbl>
+          </a:graphicData>
+        </a:graphic>
+      </p:graphicFrame>
+      <p:sp>
+        <p:nvSpPr>
+          <p:cNvPr id="8" name="TextBox 7"/>
+          <p:cNvSpPr txBox="1"/>
+          <p:nvPr/>
+        </p:nvSpPr>
+        <p:spPr>
+          <a:xfrm>
+            <a:off x="640080" y="4663440"/>
+            <a:ext cx="10972800" cy="1645920"/>
           </a:xfrm>
           <a:prstGeom prst="rect">
             <a:avLst/>
@@ -5207,11 +5857,11 @@
                 <a:spcPts val="200"/>
               </a:spcBef>
               <a:spcAft>
-                <a:spcPts val="1200"/>
+                <a:spcPts val="1000"/>
               </a:spcAft>
             </a:pPr>
             <a:r>
-              <a:rPr sz="1700" b="1">
+              <a:rPr sz="1500" b="1">
                 <a:solidFill>
                   <a:srgbClr val="0E7C7B"/>
                 </a:solidFill>
@@ -5219,22 +5869,22 @@
               <a:t>▸  </a:t>
             </a:r>
             <a:r>
-              <a:rPr sz="1700" b="1">
+              <a:rPr sz="1500" b="1">
                 <a:solidFill>
                   <a:srgbClr val="1B2A4E"/>
                 </a:solidFill>
                 <a:latin typeface="Calibri"/>
               </a:rPr>
-              <a:t>Light context</a:t>
-            </a:r>
-            <a:r>
-              <a:rPr sz="1700" b="0">
+              <a:t>Mixed / near-neutral</a:t>
+            </a:r>
+            <a:r>
+              <a:rPr sz="1500" b="0">
                 <a:solidFill>
                   <a:srgbClr val="555555"/>
                 </a:solidFill>
                 <a:latin typeface="Calibri"/>
               </a:rPr>
-              <a:t> — Δd/Δt only; add time-of-day, opening hours, queuing.</a:t>
+              <a:t> — a clear gain on Glasgow (+0.038), roughly neutral on Osaka and Toronto.</a:t>
             </a:r>
           </a:p>
           <a:p>
@@ -5243,11 +5893,11 @@
                 <a:spcPts val="200"/>
               </a:spcBef>
               <a:spcAft>
-                <a:spcPts val="1200"/>
+                <a:spcPts val="1000"/>
               </a:spcAft>
             </a:pPr>
             <a:r>
-              <a:rPr sz="1700" b="1">
+              <a:rPr sz="1500" b="1">
                 <a:solidFill>
                   <a:srgbClr val="0E7C7B"/>
                 </a:solidFill>
@@ -5255,137 +5905,29 @@
               <a:t>▸  </a:t>
             </a:r>
             <a:r>
-              <a:rPr sz="1700" b="1">
+              <a:rPr sz="1500" b="1">
                 <a:solidFill>
                   <a:srgbClr val="1B2A4E"/>
                 </a:solidFill>
                 <a:latin typeface="Calibri"/>
               </a:rPr>
-              <a:t>No scheduling</a:t>
-            </a:r>
-            <a:r>
-              <a:rPr sz="1700" b="0">
+              <a:t>Honest reason</a:t>
+            </a:r>
+            <a:r>
+              <a:rPr sz="1500" b="0">
                 <a:solidFill>
                   <a:srgbClr val="555555"/>
                 </a:solidFill>
                 <a:latin typeface="Calibri"/>
               </a:rPr>
-              <a:t> — add explicit time budgets (the DLIR direction) for realistic days.</a:t>
-            </a:r>
-          </a:p>
-          <a:p>
-            <a:pPr>
-              <a:spcBef>
-                <a:spcPts val="200"/>
-              </a:spcBef>
-              <a:spcAft>
-                <a:spcPts val="1200"/>
-              </a:spcAft>
-            </a:pPr>
-            <a:r>
-              <a:rPr sz="1700" b="1">
-                <a:solidFill>
-                  <a:srgbClr val="0E7C7B"/>
-                </a:solidFill>
-              </a:rPr>
-              <a:t>▸  </a:t>
-            </a:r>
-            <a:r>
-              <a:rPr sz="1700" b="1">
-                <a:solidFill>
-                  <a:srgbClr val="1B2A4E"/>
-                </a:solidFill>
-                <a:latin typeface="Calibri"/>
-              </a:rPr>
-              <a:t>Integrate properly</a:t>
-            </a:r>
-            <a:r>
-              <a:rPr sz="1700" b="0">
-                <a:solidFill>
-                  <a:srgbClr val="555555"/>
-                </a:solidFill>
-                <a:latin typeface="Calibri"/>
-              </a:rPr>
-              <a:t> — share/warm-start the engine with the trained model to lift it past A.</a:t>
-            </a:r>
-          </a:p>
-          <a:p>
-            <a:pPr>
-              <a:spcBef>
-                <a:spcPts val="200"/>
-              </a:spcBef>
-              <a:spcAft>
-                <a:spcPts val="1200"/>
-              </a:spcAft>
-            </a:pPr>
-            <a:r>
-              <a:rPr sz="1700" b="1">
-                <a:solidFill>
-                  <a:srgbClr val="0E7C7B"/>
-                </a:solidFill>
-              </a:rPr>
-              <a:t>▸  </a:t>
-            </a:r>
-            <a:r>
-              <a:rPr sz="1700" b="1">
-                <a:solidFill>
-                  <a:srgbClr val="1B2A4E"/>
-                </a:solidFill>
-                <a:latin typeface="Calibri"/>
-              </a:rPr>
-              <a:t>Stronger personalization</a:t>
-            </a:r>
-            <a:r>
-              <a:rPr sz="1700" b="0">
-                <a:solidFill>
-                  <a:srgbClr val="555555"/>
-                </a:solidFill>
-                <a:latin typeface="Calibri"/>
-              </a:rPr>
-              <a:t> — richer user features beyond a single embedding.</a:t>
-            </a:r>
-          </a:p>
-          <a:p>
-            <a:pPr>
-              <a:spcBef>
-                <a:spcPts val="200"/>
-              </a:spcBef>
-              <a:spcAft>
-                <a:spcPts val="1200"/>
-              </a:spcAft>
-            </a:pPr>
-            <a:r>
-              <a:rPr sz="1700" b="1">
-                <a:solidFill>
-                  <a:srgbClr val="0E7C7B"/>
-                </a:solidFill>
-              </a:rPr>
-              <a:t>▸  </a:t>
-            </a:r>
-            <a:r>
-              <a:rPr sz="1700" b="1">
-                <a:solidFill>
-                  <a:srgbClr val="1B2A4E"/>
-                </a:solidFill>
-                <a:latin typeface="Calibri"/>
-              </a:rPr>
-              <a:t>Robustness</a:t>
-            </a:r>
-            <a:r>
-              <a:rPr sz="1700" b="0">
-                <a:solidFill>
-                  <a:srgbClr val="555555"/>
-                </a:solidFill>
-                <a:latin typeface="Calibri"/>
-              </a:rPr>
-              <a:t> — multi-seed, more cities, component ablations.</a:t>
-            </a:r>
-          </a:p>
-        </p:txBody>
-      </p:sp>
-      <p:sp>
-        <p:nvSpPr>
-          <p:cNvPr id="7" name="TextBox 6"/>
+              <a:t> — in leave-one-out, even recurring users have very few trips, so the embedding is weakly estimated (cold-start). Personalization is a real lever, not a guaranteed win on small data.</a:t>
+            </a:r>
+          </a:p>
+        </p:txBody>
+      </p:sp>
+      <p:sp>
+        <p:nvSpPr>
+          <p:cNvPr id="9" name="TextBox 8"/>
           <p:cNvSpPr txBox="1"/>
           <p:nvPr/>
         </p:nvSpPr>
@@ -5420,7 +5962,7 @@
       </p:sp>
       <p:sp>
         <p:nvSpPr>
-          <p:cNvPr id="8" name="TextBox 7"/>
+          <p:cNvPr id="10" name="TextBox 9"/>
           <p:cNvSpPr txBox="1"/>
           <p:nvPr/>
         </p:nvSpPr>
@@ -5462,6 +6004,455 @@
 </file>
 
 <file path=ppt/slides/slide14.xml><?xml version="1.0" encoding="utf-8"?>
+<p:sld xmlns:a="http://schemas.openxmlformats.org/drawingml/2006/main" xmlns:p="http://schemas.openxmlformats.org/presentationml/2006/main" xmlns:r="http://schemas.openxmlformats.org/officeDocument/2006/relationships">
+  <p:cSld>
+    <p:spTree>
+      <p:nvGrpSpPr>
+        <p:cNvPr id="1" name=""/>
+        <p:cNvGrpSpPr/>
+        <p:nvPr/>
+      </p:nvGrpSpPr>
+      <p:grpSpPr/>
+      <p:sp>
+        <p:nvSpPr>
+          <p:cNvPr id="2" name="Rectangle 1"/>
+          <p:cNvSpPr/>
+          <p:nvPr/>
+        </p:nvSpPr>
+        <p:spPr>
+          <a:xfrm>
+            <a:off x="0" y="0"/>
+            <a:ext cx="12191695" cy="1051560"/>
+          </a:xfrm>
+          <a:prstGeom prst="rect">
+            <a:avLst/>
+          </a:prstGeom>
+          <a:solidFill>
+            <a:srgbClr val="1B2A4E"/>
+          </a:solidFill>
+          <a:ln>
+            <a:noFill/>
+          </a:ln>
+          <a:effectLst/>
+        </p:spPr>
+        <p:style>
+          <a:lnRef idx="1">
+            <a:schemeClr val="accent1"/>
+          </a:lnRef>
+          <a:fillRef idx="3">
+            <a:schemeClr val="accent1"/>
+          </a:fillRef>
+          <a:effectRef idx="2">
+            <a:schemeClr val="accent1"/>
+          </a:effectRef>
+          <a:fontRef idx="minor">
+            <a:schemeClr val="lt1"/>
+          </a:fontRef>
+        </p:style>
+        <p:txBody>
+          <a:bodyPr rtlCol="0" anchor="ctr"/>
+          <a:lstStyle/>
+          <a:p>
+            <a:pPr algn="ctr"/>
+          </a:p>
+        </p:txBody>
+      </p:sp>
+      <p:sp>
+        <p:nvSpPr>
+          <p:cNvPr id="3" name="Rectangle 2"/>
+          <p:cNvSpPr/>
+          <p:nvPr/>
+        </p:nvSpPr>
+        <p:spPr>
+          <a:xfrm>
+            <a:off x="0" y="1051560"/>
+            <a:ext cx="12191695" cy="54864"/>
+          </a:xfrm>
+          <a:prstGeom prst="rect">
+            <a:avLst/>
+          </a:prstGeom>
+          <a:solidFill>
+            <a:srgbClr val="0E7C7B"/>
+          </a:solidFill>
+          <a:ln>
+            <a:noFill/>
+          </a:ln>
+          <a:effectLst/>
+        </p:spPr>
+        <p:style>
+          <a:lnRef idx="1">
+            <a:schemeClr val="accent1"/>
+          </a:lnRef>
+          <a:fillRef idx="3">
+            <a:schemeClr val="accent1"/>
+          </a:fillRef>
+          <a:effectRef idx="2">
+            <a:schemeClr val="accent1"/>
+          </a:effectRef>
+          <a:fontRef idx="minor">
+            <a:schemeClr val="lt1"/>
+          </a:fontRef>
+        </p:style>
+        <p:txBody>
+          <a:bodyPr rtlCol="0" anchor="ctr"/>
+          <a:lstStyle/>
+          <a:p>
+            <a:pPr algn="ctr"/>
+          </a:p>
+        </p:txBody>
+      </p:sp>
+      <p:sp>
+        <p:nvSpPr>
+          <p:cNvPr id="4" name="TextBox 3"/>
+          <p:cNvSpPr txBox="1"/>
+          <p:nvPr/>
+        </p:nvSpPr>
+        <p:spPr>
+          <a:xfrm>
+            <a:off x="502920" y="164592"/>
+            <a:ext cx="11185855" cy="777240"/>
+          </a:xfrm>
+          <a:prstGeom prst="rect">
+            <a:avLst/>
+          </a:prstGeom>
+          <a:noFill/>
+        </p:spPr>
+        <p:txBody>
+          <a:bodyPr wrap="square" anchor="ctr">
+            <a:spAutoFit/>
+          </a:bodyPr>
+          <a:lstStyle/>
+          <a:p>
+            <a:pPr algn="l"/>
+            <a:r>
+              <a:rPr sz="2700" b="1" i="0">
+                <a:solidFill>
+                  <a:srgbClr val="FFFFFF"/>
+                </a:solidFill>
+                <a:latin typeface="Calibri"/>
+              </a:rPr>
+              <a:t>Limitations &amp; future work</a:t>
+            </a:r>
+          </a:p>
+        </p:txBody>
+      </p:sp>
+      <p:sp>
+        <p:nvSpPr>
+          <p:cNvPr id="5" name="TextBox 4"/>
+          <p:cNvSpPr txBox="1"/>
+          <p:nvPr/>
+        </p:nvSpPr>
+        <p:spPr>
+          <a:xfrm>
+            <a:off x="502920" y="36576"/>
+            <a:ext cx="11185855" cy="274320"/>
+          </a:xfrm>
+          <a:prstGeom prst="rect">
+            <a:avLst/>
+          </a:prstGeom>
+          <a:noFill/>
+        </p:spPr>
+        <p:txBody>
+          <a:bodyPr wrap="square" anchor="t">
+            <a:spAutoFit/>
+          </a:bodyPr>
+          <a:lstStyle/>
+          <a:p>
+            <a:pPr algn="l"/>
+            <a:r>
+              <a:rPr sz="1100" b="0" i="1">
+                <a:solidFill>
+                  <a:srgbClr val="BFC7D9"/>
+                </a:solidFill>
+                <a:latin typeface="Calibri"/>
+              </a:rPr>
+              <a:t>honesty</a:t>
+            </a:r>
+          </a:p>
+        </p:txBody>
+      </p:sp>
+      <p:sp>
+        <p:nvSpPr>
+          <p:cNvPr id="6" name="TextBox 5"/>
+          <p:cNvSpPr txBox="1"/>
+          <p:nvPr/>
+        </p:nvSpPr>
+        <p:spPr>
+          <a:xfrm>
+            <a:off x="640080" y="1463040"/>
+            <a:ext cx="10972800" cy="4572000"/>
+          </a:xfrm>
+          <a:prstGeom prst="rect">
+            <a:avLst/>
+          </a:prstGeom>
+          <a:noFill/>
+        </p:spPr>
+        <p:txBody>
+          <a:bodyPr wrap="square">
+            <a:spAutoFit/>
+          </a:bodyPr>
+          <a:lstStyle/>
+          <a:p>
+            <a:pPr>
+              <a:spcBef>
+                <a:spcPts val="200"/>
+              </a:spcBef>
+              <a:spcAft>
+                <a:spcPts val="1200"/>
+              </a:spcAft>
+            </a:pPr>
+            <a:r>
+              <a:rPr sz="1700" b="1">
+                <a:solidFill>
+                  <a:srgbClr val="0E7C7B"/>
+                </a:solidFill>
+              </a:rPr>
+              <a:t>▸  </a:t>
+            </a:r>
+            <a:r>
+              <a:rPr sz="1700" b="1">
+                <a:solidFill>
+                  <a:srgbClr val="1B2A4E"/>
+                </a:solidFill>
+                <a:latin typeface="Calibri"/>
+              </a:rPr>
+              <a:t>Light context</a:t>
+            </a:r>
+            <a:r>
+              <a:rPr sz="1700" b="0">
+                <a:solidFill>
+                  <a:srgbClr val="555555"/>
+                </a:solidFill>
+                <a:latin typeface="Calibri"/>
+              </a:rPr>
+              <a:t> — Δd/Δt only; add time-of-day, opening hours, queuing.</a:t>
+            </a:r>
+          </a:p>
+          <a:p>
+            <a:pPr>
+              <a:spcBef>
+                <a:spcPts val="200"/>
+              </a:spcBef>
+              <a:spcAft>
+                <a:spcPts val="1200"/>
+              </a:spcAft>
+            </a:pPr>
+            <a:r>
+              <a:rPr sz="1700" b="1">
+                <a:solidFill>
+                  <a:srgbClr val="0E7C7B"/>
+                </a:solidFill>
+              </a:rPr>
+              <a:t>▸  </a:t>
+            </a:r>
+            <a:r>
+              <a:rPr sz="1700" b="1">
+                <a:solidFill>
+                  <a:srgbClr val="1B2A4E"/>
+                </a:solidFill>
+                <a:latin typeface="Calibri"/>
+              </a:rPr>
+              <a:t>No scheduling</a:t>
+            </a:r>
+            <a:r>
+              <a:rPr sz="1700" b="0">
+                <a:solidFill>
+                  <a:srgbClr val="555555"/>
+                </a:solidFill>
+                <a:latin typeface="Calibri"/>
+              </a:rPr>
+              <a:t> — add explicit time budgets (the DLIR direction) for realistic days.</a:t>
+            </a:r>
+          </a:p>
+          <a:p>
+            <a:pPr>
+              <a:spcBef>
+                <a:spcPts val="200"/>
+              </a:spcBef>
+              <a:spcAft>
+                <a:spcPts val="1200"/>
+              </a:spcAft>
+            </a:pPr>
+            <a:r>
+              <a:rPr sz="1700" b="1">
+                <a:solidFill>
+                  <a:srgbClr val="0E7C7B"/>
+                </a:solidFill>
+              </a:rPr>
+              <a:t>▸  </a:t>
+            </a:r>
+            <a:r>
+              <a:rPr sz="1700" b="1">
+                <a:solidFill>
+                  <a:srgbClr val="1B2A4E"/>
+                </a:solidFill>
+                <a:latin typeface="Calibri"/>
+              </a:rPr>
+              <a:t>Integrate properly</a:t>
+            </a:r>
+            <a:r>
+              <a:rPr sz="1700" b="0">
+                <a:solidFill>
+                  <a:srgbClr val="555555"/>
+                </a:solidFill>
+                <a:latin typeface="Calibri"/>
+              </a:rPr>
+              <a:t> — share/warm-start the engine with the trained model to lift it past A.</a:t>
+            </a:r>
+          </a:p>
+          <a:p>
+            <a:pPr>
+              <a:spcBef>
+                <a:spcPts val="200"/>
+              </a:spcBef>
+              <a:spcAft>
+                <a:spcPts val="1200"/>
+              </a:spcAft>
+            </a:pPr>
+            <a:r>
+              <a:rPr sz="1700" b="1">
+                <a:solidFill>
+                  <a:srgbClr val="0E7C7B"/>
+                </a:solidFill>
+              </a:rPr>
+              <a:t>▸  </a:t>
+            </a:r>
+            <a:r>
+              <a:rPr sz="1700" b="1">
+                <a:solidFill>
+                  <a:srgbClr val="1B2A4E"/>
+                </a:solidFill>
+                <a:latin typeface="Calibri"/>
+              </a:rPr>
+              <a:t>Stronger personalization</a:t>
+            </a:r>
+            <a:r>
+              <a:rPr sz="1700" b="0">
+                <a:solidFill>
+                  <a:srgbClr val="555555"/>
+                </a:solidFill>
+                <a:latin typeface="Calibri"/>
+              </a:rPr>
+              <a:t> — richer user features beyond a single embedding.</a:t>
+            </a:r>
+          </a:p>
+          <a:p>
+            <a:pPr>
+              <a:spcBef>
+                <a:spcPts val="200"/>
+              </a:spcBef>
+              <a:spcAft>
+                <a:spcPts val="1200"/>
+              </a:spcAft>
+            </a:pPr>
+            <a:r>
+              <a:rPr sz="1700" b="1">
+                <a:solidFill>
+                  <a:srgbClr val="0E7C7B"/>
+                </a:solidFill>
+              </a:rPr>
+              <a:t>▸  </a:t>
+            </a:r>
+            <a:r>
+              <a:rPr sz="1700" b="1">
+                <a:solidFill>
+                  <a:srgbClr val="1B2A4E"/>
+                </a:solidFill>
+                <a:latin typeface="Calibri"/>
+              </a:rPr>
+              <a:t>Robustness</a:t>
+            </a:r>
+            <a:r>
+              <a:rPr sz="1700" b="0">
+                <a:solidFill>
+                  <a:srgbClr val="555555"/>
+                </a:solidFill>
+                <a:latin typeface="Calibri"/>
+              </a:rPr>
+              <a:t> — multi-seed, more cities, component ablations.</a:t>
+            </a:r>
+          </a:p>
+        </p:txBody>
+      </p:sp>
+      <p:sp>
+        <p:nvSpPr>
+          <p:cNvPr id="7" name="TextBox 6"/>
+          <p:cNvSpPr txBox="1"/>
+          <p:nvPr/>
+        </p:nvSpPr>
+        <p:spPr>
+          <a:xfrm>
+            <a:off x="10911535" y="6446520"/>
+            <a:ext cx="1005840" cy="274320"/>
+          </a:xfrm>
+          <a:prstGeom prst="rect">
+            <a:avLst/>
+          </a:prstGeom>
+          <a:noFill/>
+        </p:spPr>
+        <p:txBody>
+          <a:bodyPr wrap="square" anchor="t">
+            <a:spAutoFit/>
+          </a:bodyPr>
+          <a:lstStyle/>
+          <a:p>
+            <a:pPr algn="r"/>
+            <a:r>
+              <a:rPr sz="1100" b="0" i="0">
+                <a:solidFill>
+                  <a:srgbClr val="888888"/>
+                </a:solidFill>
+                <a:latin typeface="Calibri"/>
+              </a:rPr>
+              <a:t>14</a:t>
+            </a:r>
+          </a:p>
+        </p:txBody>
+      </p:sp>
+      <p:sp>
+        <p:nvSpPr>
+          <p:cNvPr id="8" name="TextBox 7"/>
+          <p:cNvSpPr txBox="1"/>
+          <p:nvPr/>
+        </p:nvSpPr>
+        <p:spPr>
+          <a:xfrm>
+            <a:off x="502920" y="6446520"/>
+            <a:ext cx="9144000" cy="274320"/>
+          </a:xfrm>
+          <a:prstGeom prst="rect">
+            <a:avLst/>
+          </a:prstGeom>
+          <a:noFill/>
+        </p:spPr>
+        <p:txBody>
+          <a:bodyPr wrap="square" anchor="t">
+            <a:spAutoFit/>
+          </a:bodyPr>
+          <a:lstStyle/>
+          <a:p>
+            <a:pPr algn="l"/>
+            <a:r>
+              <a:rPr sz="900" b="0" i="1">
+                <a:solidFill>
+                  <a:srgbClr val="888888"/>
+                </a:solidFill>
+                <a:latin typeface="Calibri"/>
+              </a:rPr>
+              <a:t>A personalized, context-aware itinerary recommender</a:t>
+            </a:r>
+          </a:p>
+        </p:txBody>
+      </p:sp>
+    </p:spTree>
+  </p:cSld>
+  <p:clrMapOvr>
+    <a:masterClrMapping/>
+  </p:clrMapOvr>
+</p:sld>
+</file>
+
+<file path=ppt/slides/slide15.xml><?xml version="1.0" encoding="utf-8"?>
 <p:sld xmlns:a="http://schemas.openxmlformats.org/drawingml/2006/main" xmlns:p="http://schemas.openxmlformats.org/presentationml/2006/main" xmlns:r="http://schemas.openxmlformats.org/officeDocument/2006/relationships">
   <p:cSld>
     <p:spTree>

</xml_diff>